<commit_message>
Updated sex data hierarchy
</commit_message>
<xml_diff>
--- a/supporting documentation/sex-tb-prev-analysis-data-hierarchy.pptx
+++ b/supporting documentation/sex-tb-prev-analysis-data-hierarchy.pptx
@@ -257,7 +257,7 @@
           <a:p>
             <a:fld id="{36741E12-3080-894E-8286-9EAD400DCC7E}" type="datetimeFigureOut">
               <a:rPr lang="en-US" smtClean="0"/>
-              <a:t>3/6/25</a:t>
+              <a:t>3/19/25</a:t>
             </a:fld>
             <a:endParaRPr lang="en-US"/>
           </a:p>
@@ -935,7 +935,7 @@
           <a:p>
             <a:fld id="{579E70C8-8152-AA42-B231-9775CDC57791}" type="datetimeFigureOut">
               <a:rPr lang="en-US" smtClean="0"/>
-              <a:t>3/6/25</a:t>
+              <a:t>3/19/25</a:t>
             </a:fld>
             <a:endParaRPr lang="en-US"/>
           </a:p>
@@ -1105,7 +1105,7 @@
           <a:p>
             <a:fld id="{579E70C8-8152-AA42-B231-9775CDC57791}" type="datetimeFigureOut">
               <a:rPr lang="en-US" smtClean="0"/>
-              <a:t>3/6/25</a:t>
+              <a:t>3/19/25</a:t>
             </a:fld>
             <a:endParaRPr lang="en-US"/>
           </a:p>
@@ -1285,7 +1285,7 @@
           <a:p>
             <a:fld id="{579E70C8-8152-AA42-B231-9775CDC57791}" type="datetimeFigureOut">
               <a:rPr lang="en-US" smtClean="0"/>
-              <a:t>3/6/25</a:t>
+              <a:t>3/19/25</a:t>
             </a:fld>
             <a:endParaRPr lang="en-US"/>
           </a:p>
@@ -1455,7 +1455,7 @@
           <a:p>
             <a:fld id="{579E70C8-8152-AA42-B231-9775CDC57791}" type="datetimeFigureOut">
               <a:rPr lang="en-US" smtClean="0"/>
-              <a:t>3/6/25</a:t>
+              <a:t>3/19/25</a:t>
             </a:fld>
             <a:endParaRPr lang="en-US"/>
           </a:p>
@@ -1701,7 +1701,7 @@
           <a:p>
             <a:fld id="{579E70C8-8152-AA42-B231-9775CDC57791}" type="datetimeFigureOut">
               <a:rPr lang="en-US" smtClean="0"/>
-              <a:t>3/6/25</a:t>
+              <a:t>3/19/25</a:t>
             </a:fld>
             <a:endParaRPr lang="en-US"/>
           </a:p>
@@ -1933,7 +1933,7 @@
           <a:p>
             <a:fld id="{579E70C8-8152-AA42-B231-9775CDC57791}" type="datetimeFigureOut">
               <a:rPr lang="en-US" smtClean="0"/>
-              <a:t>3/6/25</a:t>
+              <a:t>3/19/25</a:t>
             </a:fld>
             <a:endParaRPr lang="en-US"/>
           </a:p>
@@ -2300,7 +2300,7 @@
           <a:p>
             <a:fld id="{579E70C8-8152-AA42-B231-9775CDC57791}" type="datetimeFigureOut">
               <a:rPr lang="en-US" smtClean="0"/>
-              <a:t>3/6/25</a:t>
+              <a:t>3/19/25</a:t>
             </a:fld>
             <a:endParaRPr lang="en-US"/>
           </a:p>
@@ -2418,7 +2418,7 @@
           <a:p>
             <a:fld id="{579E70C8-8152-AA42-B231-9775CDC57791}" type="datetimeFigureOut">
               <a:rPr lang="en-US" smtClean="0"/>
-              <a:t>3/6/25</a:t>
+              <a:t>3/19/25</a:t>
             </a:fld>
             <a:endParaRPr lang="en-US"/>
           </a:p>
@@ -2513,7 +2513,7 @@
           <a:p>
             <a:fld id="{579E70C8-8152-AA42-B231-9775CDC57791}" type="datetimeFigureOut">
               <a:rPr lang="en-US" smtClean="0"/>
-              <a:t>3/6/25</a:t>
+              <a:t>3/19/25</a:t>
             </a:fld>
             <a:endParaRPr lang="en-US"/>
           </a:p>
@@ -2790,7 +2790,7 @@
           <a:p>
             <a:fld id="{579E70C8-8152-AA42-B231-9775CDC57791}" type="datetimeFigureOut">
               <a:rPr lang="en-US" smtClean="0"/>
-              <a:t>3/6/25</a:t>
+              <a:t>3/19/25</a:t>
             </a:fld>
             <a:endParaRPr lang="en-US"/>
           </a:p>
@@ -3047,7 +3047,7 @@
           <a:p>
             <a:fld id="{579E70C8-8152-AA42-B231-9775CDC57791}" type="datetimeFigureOut">
               <a:rPr lang="en-US" smtClean="0"/>
-              <a:t>3/6/25</a:t>
+              <a:t>3/19/25</a:t>
             </a:fld>
             <a:endParaRPr lang="en-US"/>
           </a:p>
@@ -3260,7 +3260,7 @@
           <a:p>
             <a:fld id="{579E70C8-8152-AA42-B231-9775CDC57791}" type="datetimeFigureOut">
               <a:rPr lang="en-US" smtClean="0"/>
-              <a:t>3/6/25</a:t>
+              <a:t>3/19/25</a:t>
             </a:fld>
             <a:endParaRPr lang="en-US"/>
           </a:p>
@@ -5943,7 +5943,7 @@
             <a:pPr algn="ctr"/>
             <a:r>
               <a:rPr lang="en-US" sz="1200" b="1" dirty="0"/>
-              <a:t>19 BACT</a:t>
+              <a:t>20 BACT</a:t>
             </a:r>
           </a:p>
           <a:p>
@@ -6050,7 +6050,7 @@
             <a:pPr algn="ctr"/>
             <a:r>
               <a:rPr lang="en-US" sz="1200" b="1" dirty="0"/>
-              <a:t>9</a:t>
+              <a:t>8</a:t>
             </a:r>
           </a:p>
           <a:p>
@@ -6143,7 +6143,7 @@
             <a:pPr algn="ctr"/>
             <a:r>
               <a:rPr lang="en-US" sz="1400" b="1" dirty="0"/>
-              <a:t>98 surveys total included</a:t>
+              <a:t>99 surveys total included</a:t>
             </a:r>
           </a:p>
         </p:txBody>

</xml_diff>

<commit_message>
mass commit computer problems
</commit_message>
<xml_diff>
--- a/supporting documentation/sex-tb-prev-analysis-data-hierarchy.pptx
+++ b/supporting documentation/sex-tb-prev-analysis-data-hierarchy.pptx
@@ -257,7 +257,7 @@
           <a:p>
             <a:fld id="{36741E12-3080-894E-8286-9EAD400DCC7E}" type="datetimeFigureOut">
               <a:rPr lang="en-US" smtClean="0"/>
-              <a:t>3/19/25</a:t>
+              <a:t>3/10/26</a:t>
             </a:fld>
             <a:endParaRPr lang="en-US"/>
           </a:p>
@@ -935,7 +935,7 @@
           <a:p>
             <a:fld id="{579E70C8-8152-AA42-B231-9775CDC57791}" type="datetimeFigureOut">
               <a:rPr lang="en-US" smtClean="0"/>
-              <a:t>3/19/25</a:t>
+              <a:t>3/10/26</a:t>
             </a:fld>
             <a:endParaRPr lang="en-US"/>
           </a:p>
@@ -1105,7 +1105,7 @@
           <a:p>
             <a:fld id="{579E70C8-8152-AA42-B231-9775CDC57791}" type="datetimeFigureOut">
               <a:rPr lang="en-US" smtClean="0"/>
-              <a:t>3/19/25</a:t>
+              <a:t>3/10/26</a:t>
             </a:fld>
             <a:endParaRPr lang="en-US"/>
           </a:p>
@@ -1285,7 +1285,7 @@
           <a:p>
             <a:fld id="{579E70C8-8152-AA42-B231-9775CDC57791}" type="datetimeFigureOut">
               <a:rPr lang="en-US" smtClean="0"/>
-              <a:t>3/19/25</a:t>
+              <a:t>3/10/26</a:t>
             </a:fld>
             <a:endParaRPr lang="en-US"/>
           </a:p>
@@ -1455,7 +1455,7 @@
           <a:p>
             <a:fld id="{579E70C8-8152-AA42-B231-9775CDC57791}" type="datetimeFigureOut">
               <a:rPr lang="en-US" smtClean="0"/>
-              <a:t>3/19/25</a:t>
+              <a:t>3/10/26</a:t>
             </a:fld>
             <a:endParaRPr lang="en-US"/>
           </a:p>
@@ -1701,7 +1701,7 @@
           <a:p>
             <a:fld id="{579E70C8-8152-AA42-B231-9775CDC57791}" type="datetimeFigureOut">
               <a:rPr lang="en-US" smtClean="0"/>
-              <a:t>3/19/25</a:t>
+              <a:t>3/10/26</a:t>
             </a:fld>
             <a:endParaRPr lang="en-US"/>
           </a:p>
@@ -1933,7 +1933,7 @@
           <a:p>
             <a:fld id="{579E70C8-8152-AA42-B231-9775CDC57791}" type="datetimeFigureOut">
               <a:rPr lang="en-US" smtClean="0"/>
-              <a:t>3/19/25</a:t>
+              <a:t>3/10/26</a:t>
             </a:fld>
             <a:endParaRPr lang="en-US"/>
           </a:p>
@@ -2300,7 +2300,7 @@
           <a:p>
             <a:fld id="{579E70C8-8152-AA42-B231-9775CDC57791}" type="datetimeFigureOut">
               <a:rPr lang="en-US" smtClean="0"/>
-              <a:t>3/19/25</a:t>
+              <a:t>3/10/26</a:t>
             </a:fld>
             <a:endParaRPr lang="en-US"/>
           </a:p>
@@ -2418,7 +2418,7 @@
           <a:p>
             <a:fld id="{579E70C8-8152-AA42-B231-9775CDC57791}" type="datetimeFigureOut">
               <a:rPr lang="en-US" smtClean="0"/>
-              <a:t>3/19/25</a:t>
+              <a:t>3/10/26</a:t>
             </a:fld>
             <a:endParaRPr lang="en-US"/>
           </a:p>
@@ -2513,7 +2513,7 @@
           <a:p>
             <a:fld id="{579E70C8-8152-AA42-B231-9775CDC57791}" type="datetimeFigureOut">
               <a:rPr lang="en-US" smtClean="0"/>
-              <a:t>3/19/25</a:t>
+              <a:t>3/10/26</a:t>
             </a:fld>
             <a:endParaRPr lang="en-US"/>
           </a:p>
@@ -2790,7 +2790,7 @@
           <a:p>
             <a:fld id="{579E70C8-8152-AA42-B231-9775CDC57791}" type="datetimeFigureOut">
               <a:rPr lang="en-US" smtClean="0"/>
-              <a:t>3/19/25</a:t>
+              <a:t>3/10/26</a:t>
             </a:fld>
             <a:endParaRPr lang="en-US"/>
           </a:p>
@@ -3047,7 +3047,7 @@
           <a:p>
             <a:fld id="{579E70C8-8152-AA42-B231-9775CDC57791}" type="datetimeFigureOut">
               <a:rPr lang="en-US" smtClean="0"/>
-              <a:t>3/19/25</a:t>
+              <a:t>3/10/26</a:t>
             </a:fld>
             <a:endParaRPr lang="en-US"/>
           </a:p>
@@ -3260,7 +3260,7 @@
           <a:p>
             <a:fld id="{579E70C8-8152-AA42-B231-9775CDC57791}" type="datetimeFigureOut">
               <a:rPr lang="en-US" smtClean="0"/>
-              <a:t>3/19/25</a:t>
+              <a:t>3/10/26</a:t>
             </a:fld>
             <a:endParaRPr lang="en-US"/>
           </a:p>
@@ -5843,7 +5843,7 @@
             <a:pPr algn="ctr"/>
             <a:r>
               <a:rPr lang="en-US" sz="1200" b="1" dirty="0"/>
-              <a:t>43 BACT</a:t>
+              <a:t>45 BACT</a:t>
             </a:r>
           </a:p>
           <a:p>
@@ -5893,7 +5893,7 @@
             <a:pPr algn="ctr"/>
             <a:r>
               <a:rPr lang="en-US" sz="1200" b="1" dirty="0"/>
-              <a:t>9 BACT</a:t>
+              <a:t>10 BACT</a:t>
             </a:r>
           </a:p>
           <a:p>
@@ -6142,8 +6142,12 @@
           <a:p>
             <a:pPr algn="ctr"/>
             <a:r>
+              <a:rPr lang="en-US" sz="1400" b="1"/>
+              <a:t>102 </a:t>
+            </a:r>
+            <a:r>
               <a:rPr lang="en-US" sz="1400" b="1" dirty="0"/>
-              <a:t>99 surveys total included</a:t>
+              <a:t>surveys total included</a:t>
             </a:r>
           </a:p>
         </p:txBody>

</xml_diff>